<commit_message>
Reconcile D4 style guide with what's actually shipped
Found via direct color-value comparison: the deck used slightly
different neutral text shades (1E293B/64748B) than the dashboard's
documented ones (0F172A/475569), and STYLE_GUIDE.md never described
the deck's own Ocean Gradient brand colors at all - it only described
the dashboard.

Fixed the actual mismatch (deck now uses the dashboard's exact neutral
values, re-rendered and re-verified with no visual regression), then
rewrote STYLE_GUIDE.md to honestly document both layers: the risk ramp
(functional, shared everywhere) and the Ocean Gradient (deck-only
brand identity), plus why deck vs. dashboard typography intentionally
differs by medium rather than pretending it should be identical.
</commit_message>
<xml_diff>
--- a/D_dashboard/deck/Dugong_Watch_Overview.pptx
+++ b/D_dashboard/deck/Dugong_Watch_Overview.pptx
@@ -1861,7 +1861,7 @@
             <a:r>
               <a:rPr lang="en-US" sz="1300" dirty="0">
                 <a:solidFill>
-                  <a:srgbClr val="64748B"/>
+                  <a:srgbClr val="475569"/>
                 </a:solidFill>
                 <a:latin typeface="Calibri" pitchFamily="34" charset="0"/>
                 <a:ea typeface="Calibri" pitchFamily="34" charset="-122"/>
@@ -1983,7 +1983,7 @@
             <a:r>
               <a:rPr lang="en-US" sz="1300" dirty="0">
                 <a:solidFill>
-                  <a:srgbClr val="64748B"/>
+                  <a:srgbClr val="475569"/>
                 </a:solidFill>
                 <a:latin typeface="Calibri" pitchFamily="34" charset="0"/>
                 <a:ea typeface="Calibri" pitchFamily="34" charset="-122"/>
@@ -2105,7 +2105,7 @@
             <a:r>
               <a:rPr lang="en-US" sz="1300" dirty="0">
                 <a:solidFill>
-                  <a:srgbClr val="64748B"/>
+                  <a:srgbClr val="475569"/>
                 </a:solidFill>
                 <a:latin typeface="Calibri" pitchFamily="34" charset="0"/>
                 <a:ea typeface="Calibri" pitchFamily="34" charset="-122"/>
@@ -2215,7 +2215,7 @@
             <a:r>
               <a:rPr lang="en-US" sz="1300" i="1" dirty="0">
                 <a:solidFill>
-                  <a:srgbClr val="64748B"/>
+                  <a:srgbClr val="475569"/>
                 </a:solidFill>
                 <a:latin typeface="Calibri" pitchFamily="34" charset="0"/>
                 <a:ea typeface="Calibri" pitchFamily="34" charset="-122"/>
@@ -2424,7 +2424,7 @@
             <a:r>
               <a:rPr lang="en-US" sz="1600" b="1" dirty="0">
                 <a:solidFill>
-                  <a:srgbClr val="64748B"/>
+                  <a:srgbClr val="475569"/>
                 </a:solidFill>
               </a:rPr>
               <a:t>›</a:t>
@@ -2630,7 +2630,7 @@
             <a:r>
               <a:rPr lang="en-US" sz="1600" b="1" dirty="0">
                 <a:solidFill>
-                  <a:srgbClr val="64748B"/>
+                  <a:srgbClr val="475569"/>
                 </a:solidFill>
               </a:rPr>
               <a:t>›</a:t>
@@ -2836,7 +2836,7 @@
             <a:r>
               <a:rPr lang="en-US" sz="1600" b="1" dirty="0">
                 <a:solidFill>
-                  <a:srgbClr val="64748B"/>
+                  <a:srgbClr val="475569"/>
                 </a:solidFill>
               </a:rPr>
               <a:t>›</a:t>
@@ -3042,7 +3042,7 @@
             <a:r>
               <a:rPr lang="en-US" sz="1600" b="1" dirty="0">
                 <a:solidFill>
-                  <a:srgbClr val="64748B"/>
+                  <a:srgbClr val="475569"/>
                 </a:solidFill>
               </a:rPr>
               <a:t>›</a:t>
@@ -3358,7 +3358,7 @@
             <a:r>
               <a:rPr lang="en-US" sz="1300" dirty="0">
                 <a:solidFill>
-                  <a:srgbClr val="64748B"/>
+                  <a:srgbClr val="475569"/>
                 </a:solidFill>
                 <a:latin typeface="Calibri" pitchFamily="34" charset="0"/>
                 <a:ea typeface="Calibri" pitchFamily="34" charset="-122"/>
@@ -3595,7 +3595,7 @@
             <a:r>
               <a:rPr lang="en-US" sz="1250" dirty="0">
                 <a:solidFill>
-                  <a:srgbClr val="64748B"/>
+                  <a:srgbClr val="475569"/>
                 </a:solidFill>
                 <a:latin typeface="Calibri" pitchFamily="34" charset="0"/>
                 <a:ea typeface="Calibri" pitchFamily="34" charset="-122"/>
@@ -3702,7 +3702,7 @@
             <a:r>
               <a:rPr lang="en-US" sz="1100" dirty="0">
                 <a:solidFill>
-                  <a:srgbClr val="64748B"/>
+                  <a:srgbClr val="475569"/>
                 </a:solidFill>
                 <a:latin typeface="Calibri" pitchFamily="34" charset="0"/>
                 <a:ea typeface="Calibri" pitchFamily="34" charset="-122"/>
@@ -3809,7 +3809,7 @@
             <a:r>
               <a:rPr lang="en-US" sz="1100" dirty="0">
                 <a:solidFill>
-                  <a:srgbClr val="64748B"/>
+                  <a:srgbClr val="475569"/>
                 </a:solidFill>
                 <a:latin typeface="Calibri" pitchFamily="34" charset="0"/>
                 <a:ea typeface="Calibri" pitchFamily="34" charset="-122"/>
@@ -3943,7 +3943,7 @@
             <a:r>
               <a:rPr lang="en-US" sz="1350" dirty="0">
                 <a:solidFill>
-                  <a:srgbClr val="64748B"/>
+                  <a:srgbClr val="475569"/>
                 </a:solidFill>
                 <a:latin typeface="Calibri" pitchFamily="34" charset="0"/>
                 <a:ea typeface="Calibri" pitchFamily="34" charset="-122"/>

</xml_diff>